<commit_message>
knf 덱 32개·일자별 통합본: deckgen v2.0.1(정본 aebonlee/deckgen)로 다시 구움 — 도형 차이 0
Co-Authored-By: Claude Opus 5.5 <noreply@anthropic.com>
</commit_message>
<xml_diff>
--- a/knf/decks/d1p2.pptx
+++ b/knf/decks/d1p2.pptx
@@ -3100,7 +3100,7 @@
       <p:grpSpPr/>
       <p:sp>
         <p:nvSpPr>
-          <p:cNvPr id="2" name="Oval 1"/>
+          <p:cNvPr id="2" name="deckgen:decor"/>
           <p:cNvSpPr/>
           <p:nvPr/>
         </p:nvSpPr>
@@ -3130,7 +3130,7 @@
       </p:sp>
       <p:sp>
         <p:nvSpPr>
-          <p:cNvPr id="3" name="Oval 2"/>
+          <p:cNvPr id="3" name="deckgen:decor"/>
           <p:cNvSpPr/>
           <p:nvPr/>
         </p:nvSpPr>
@@ -3160,7 +3160,7 @@
       </p:sp>
       <p:sp>
         <p:nvSpPr>
-          <p:cNvPr id="4" name="Oval 3"/>
+          <p:cNvPr id="4" name="deckgen:decor"/>
           <p:cNvSpPr/>
           <p:nvPr/>
         </p:nvSpPr>
@@ -3190,7 +3190,7 @@
       </p:sp>
       <p:sp>
         <p:nvSpPr>
-          <p:cNvPr id="5" name="Rectangle 4"/>
+          <p:cNvPr id="5" name="deckgen:decor"/>
           <p:cNvSpPr/>
           <p:nvPr/>
         </p:nvSpPr>
@@ -3220,7 +3220,7 @@
       </p:sp>
       <p:sp>
         <p:nvSpPr>
-          <p:cNvPr id="6" name="Oval 5"/>
+          <p:cNvPr id="6" name="deckgen:decor"/>
           <p:cNvSpPr/>
           <p:nvPr/>
         </p:nvSpPr>
@@ -3250,7 +3250,7 @@
       </p:sp>
       <p:sp>
         <p:nvSpPr>
-          <p:cNvPr id="7" name="Oval 6"/>
+          <p:cNvPr id="7" name="deckgen:decor"/>
           <p:cNvSpPr/>
           <p:nvPr/>
         </p:nvSpPr>
@@ -3280,7 +3280,7 @@
       </p:sp>
       <p:sp>
         <p:nvSpPr>
-          <p:cNvPr id="8" name="Oval 7"/>
+          <p:cNvPr id="8" name="deckgen:decor"/>
           <p:cNvSpPr/>
           <p:nvPr/>
         </p:nvSpPr>
@@ -3310,7 +3310,7 @@
       </p:sp>
       <p:sp>
         <p:nvSpPr>
-          <p:cNvPr id="9" name="Oval 8"/>
+          <p:cNvPr id="9" name="deckgen:decor"/>
           <p:cNvSpPr/>
           <p:nvPr/>
         </p:nvSpPr>
@@ -3340,7 +3340,7 @@
       </p:sp>
       <p:sp>
         <p:nvSpPr>
-          <p:cNvPr id="10" name="Rectangle 9"/>
+          <p:cNvPr id="10" name="deckgen:decor"/>
           <p:cNvSpPr/>
           <p:nvPr/>
         </p:nvSpPr>
@@ -3618,7 +3618,7 @@
       <p:grpSpPr/>
       <p:sp>
         <p:nvSpPr>
-          <p:cNvPr id="2" name="Oval 1"/>
+          <p:cNvPr id="2" name="deckgen:decor"/>
           <p:cNvSpPr/>
           <p:nvPr/>
         </p:nvSpPr>
@@ -3648,7 +3648,7 @@
       </p:sp>
       <p:sp>
         <p:nvSpPr>
-          <p:cNvPr id="3" name="Oval 2"/>
+          <p:cNvPr id="3" name="deckgen:decor"/>
           <p:cNvSpPr/>
           <p:nvPr/>
         </p:nvSpPr>
@@ -3678,7 +3678,7 @@
       </p:sp>
       <p:sp>
         <p:nvSpPr>
-          <p:cNvPr id="4" name="Oval 3"/>
+          <p:cNvPr id="4" name="deckgen:decor"/>
           <p:cNvSpPr/>
           <p:nvPr/>
         </p:nvSpPr>
@@ -4534,7 +4534,7 @@
       <p:grpSpPr/>
       <p:sp>
         <p:nvSpPr>
-          <p:cNvPr id="2" name="Oval 1"/>
+          <p:cNvPr id="2" name="deckgen:decor"/>
           <p:cNvSpPr/>
           <p:nvPr/>
         </p:nvSpPr>
@@ -4564,7 +4564,7 @@
       </p:sp>
       <p:sp>
         <p:nvSpPr>
-          <p:cNvPr id="3" name="Oval 2"/>
+          <p:cNvPr id="3" name="deckgen:decor"/>
           <p:cNvSpPr/>
           <p:nvPr/>
         </p:nvSpPr>
@@ -5341,7 +5341,7 @@
       <p:grpSpPr/>
       <p:sp>
         <p:nvSpPr>
-          <p:cNvPr id="2" name="Oval 1"/>
+          <p:cNvPr id="2" name="deckgen:decor"/>
           <p:cNvSpPr/>
           <p:nvPr/>
         </p:nvSpPr>
@@ -5371,7 +5371,7 @@
       </p:sp>
       <p:sp>
         <p:nvSpPr>
-          <p:cNvPr id="3" name="Oval 2"/>
+          <p:cNvPr id="3" name="deckgen:decor"/>
           <p:cNvSpPr/>
           <p:nvPr/>
         </p:nvSpPr>
@@ -5401,7 +5401,7 @@
       </p:sp>
       <p:sp>
         <p:nvSpPr>
-          <p:cNvPr id="4" name="Oval 3"/>
+          <p:cNvPr id="4" name="deckgen:decor"/>
           <p:cNvSpPr/>
           <p:nvPr/>
         </p:nvSpPr>
@@ -6186,7 +6186,7 @@
       <p:grpSpPr/>
       <p:sp>
         <p:nvSpPr>
-          <p:cNvPr id="2" name="Oval 1"/>
+          <p:cNvPr id="2" name="deckgen:decor"/>
           <p:cNvSpPr/>
           <p:nvPr/>
         </p:nvSpPr>
@@ -6216,7 +6216,7 @@
       </p:sp>
       <p:sp>
         <p:nvSpPr>
-          <p:cNvPr id="3" name="Oval 2"/>
+          <p:cNvPr id="3" name="deckgen:decor"/>
           <p:cNvSpPr/>
           <p:nvPr/>
         </p:nvSpPr>
@@ -6246,7 +6246,7 @@
       </p:sp>
       <p:sp>
         <p:nvSpPr>
-          <p:cNvPr id="4" name="Oval 3"/>
+          <p:cNvPr id="4" name="deckgen:decor"/>
           <p:cNvSpPr/>
           <p:nvPr/>
         </p:nvSpPr>
@@ -8122,7 +8122,7 @@
       <p:grpSpPr/>
       <p:sp>
         <p:nvSpPr>
-          <p:cNvPr id="2" name="Oval 1"/>
+          <p:cNvPr id="2" name="deckgen:decor"/>
           <p:cNvSpPr/>
           <p:nvPr/>
         </p:nvSpPr>
@@ -8152,7 +8152,7 @@
       </p:sp>
       <p:sp>
         <p:nvSpPr>
-          <p:cNvPr id="3" name="Oval 2"/>
+          <p:cNvPr id="3" name="deckgen:decor"/>
           <p:cNvSpPr/>
           <p:nvPr/>
         </p:nvSpPr>
@@ -8182,7 +8182,7 @@
       </p:sp>
       <p:sp>
         <p:nvSpPr>
-          <p:cNvPr id="4" name="Oval 3"/>
+          <p:cNvPr id="4" name="deckgen:decor"/>
           <p:cNvSpPr/>
           <p:nvPr/>
         </p:nvSpPr>
@@ -9198,7 +9198,7 @@
       <p:grpSpPr/>
       <p:sp>
         <p:nvSpPr>
-          <p:cNvPr id="2" name="Oval 1"/>
+          <p:cNvPr id="2" name="deckgen:decor"/>
           <p:cNvSpPr/>
           <p:nvPr/>
         </p:nvSpPr>
@@ -9228,7 +9228,7 @@
       </p:sp>
       <p:sp>
         <p:nvSpPr>
-          <p:cNvPr id="3" name="Oval 2"/>
+          <p:cNvPr id="3" name="deckgen:decor"/>
           <p:cNvSpPr/>
           <p:nvPr/>
         </p:nvSpPr>
@@ -9258,7 +9258,7 @@
       </p:sp>
       <p:sp>
         <p:nvSpPr>
-          <p:cNvPr id="4" name="Oval 3"/>
+          <p:cNvPr id="4" name="deckgen:decor"/>
           <p:cNvSpPr/>
           <p:nvPr/>
         </p:nvSpPr>
@@ -10318,7 +10318,7 @@
       <p:grpSpPr/>
       <p:sp>
         <p:nvSpPr>
-          <p:cNvPr id="2" name="Oval 1"/>
+          <p:cNvPr id="2" name="deckgen:decor"/>
           <p:cNvSpPr/>
           <p:nvPr/>
         </p:nvSpPr>
@@ -10348,7 +10348,7 @@
       </p:sp>
       <p:sp>
         <p:nvSpPr>
-          <p:cNvPr id="3" name="Oval 2"/>
+          <p:cNvPr id="3" name="deckgen:decor"/>
           <p:cNvSpPr/>
           <p:nvPr/>
         </p:nvSpPr>
@@ -10378,7 +10378,7 @@
       </p:sp>
       <p:sp>
         <p:nvSpPr>
-          <p:cNvPr id="4" name="Oval 3"/>
+          <p:cNvPr id="4" name="deckgen:decor"/>
           <p:cNvSpPr/>
           <p:nvPr/>
         </p:nvSpPr>
@@ -11804,7 +11804,7 @@
       <p:grpSpPr/>
       <p:sp>
         <p:nvSpPr>
-          <p:cNvPr id="2" name="Oval 1"/>
+          <p:cNvPr id="2" name="deckgen:decor"/>
           <p:cNvSpPr/>
           <p:nvPr/>
         </p:nvSpPr>
@@ -11834,7 +11834,7 @@
       </p:sp>
       <p:sp>
         <p:nvSpPr>
-          <p:cNvPr id="3" name="Oval 2"/>
+          <p:cNvPr id="3" name="deckgen:decor"/>
           <p:cNvSpPr/>
           <p:nvPr/>
         </p:nvSpPr>
@@ -11864,7 +11864,7 @@
       </p:sp>
       <p:sp>
         <p:nvSpPr>
-          <p:cNvPr id="4" name="Oval 3"/>
+          <p:cNvPr id="4" name="deckgen:decor"/>
           <p:cNvSpPr/>
           <p:nvPr/>
         </p:nvSpPr>
@@ -12865,7 +12865,7 @@
       <p:grpSpPr/>
       <p:sp>
         <p:nvSpPr>
-          <p:cNvPr id="2" name="Oval 1"/>
+          <p:cNvPr id="2" name="deckgen:decor"/>
           <p:cNvSpPr/>
           <p:nvPr/>
         </p:nvSpPr>
@@ -12895,7 +12895,7 @@
       </p:sp>
       <p:sp>
         <p:nvSpPr>
-          <p:cNvPr id="3" name="Oval 2"/>
+          <p:cNvPr id="3" name="deckgen:decor"/>
           <p:cNvSpPr/>
           <p:nvPr/>
         </p:nvSpPr>
@@ -12925,7 +12925,7 @@
       </p:sp>
       <p:sp>
         <p:nvSpPr>
-          <p:cNvPr id="4" name="Oval 3"/>
+          <p:cNvPr id="4" name="deckgen:decor"/>
           <p:cNvSpPr/>
           <p:nvPr/>
         </p:nvSpPr>
@@ -13892,7 +13892,7 @@
       <p:grpSpPr/>
       <p:sp>
         <p:nvSpPr>
-          <p:cNvPr id="2" name="Oval 1"/>
+          <p:cNvPr id="2" name="deckgen:decor"/>
           <p:cNvSpPr/>
           <p:nvPr/>
         </p:nvSpPr>
@@ -13922,7 +13922,7 @@
       </p:sp>
       <p:sp>
         <p:nvSpPr>
-          <p:cNvPr id="3" name="Oval 2"/>
+          <p:cNvPr id="3" name="deckgen:decor"/>
           <p:cNvSpPr/>
           <p:nvPr/>
         </p:nvSpPr>
@@ -13952,7 +13952,7 @@
       </p:sp>
       <p:sp>
         <p:nvSpPr>
-          <p:cNvPr id="4" name="Oval 3"/>
+          <p:cNvPr id="4" name="deckgen:decor"/>
           <p:cNvSpPr/>
           <p:nvPr/>
         </p:nvSpPr>

</xml_diff>